<commit_message>
v6: ppt — fix manifest scanner rule count 8 → 12 in Blueprint-and-Flow
Two slides had stale count (8 rules). Updated to 12 to match the actual
rule_id entries in manifest_scanner/rules.py and the SVG in the HTML report.
Semgrep (19) and Copilot (68) were already correct in the PPT.

Co-Authored-By: Claude Sonnet 4.6 <noreply@anthropic.com>
</commit_message>
<xml_diff>
--- a/ppt/AgentShield-Blueprint-and-Flow.pptx
+++ b/ppt/AgentShield-Blueprint-and-Flow.pptx
@@ -1245,7 +1245,7 @@
 </p:sldMaster>
 </file>
 
-<file path=ppt/slides/slide3.xml><?xml version="1.0" encoding="utf-8"?>
+<file path=ppt/slides/slide1.xml><?xml version="1.0" encoding="utf-8"?>
 <p:sld xmlns:a="http://schemas.openxmlformats.org/drawingml/2006/main" xmlns:r="http://schemas.openxmlformats.org/officeDocument/2006/relationships" xmlns:p="http://schemas.openxmlformats.org/presentationml/2006/main">
   <p:cSld name="Slide 3">
     <p:bg>
@@ -1373,6 +1373,10 @@
             <a:prstDash val="solid"/>
           </a:ln>
         </p:spPr>
+        <p:txBody>
+          <a:bodyPr/>
+          <a:p/>
+        </p:txBody>
       </p:sp>
       <p:sp>
         <p:nvSpPr>
@@ -1398,6 +1402,10 @@
             <a:prstDash val="solid"/>
           </a:ln>
         </p:spPr>
+        <p:txBody>
+          <a:bodyPr/>
+          <a:p/>
+        </p:txBody>
       </p:sp>
       <p:sp>
         <p:nvSpPr>
@@ -1542,6 +1550,10 @@
             <a:prstDash val="solid"/>
           </a:ln>
         </p:spPr>
+        <p:txBody>
+          <a:bodyPr/>
+          <a:p/>
+        </p:txBody>
       </p:sp>
       <p:sp>
         <p:nvSpPr>
@@ -1567,6 +1579,10 @@
             <a:prstDash val="solid"/>
           </a:ln>
         </p:spPr>
+        <p:txBody>
+          <a:bodyPr/>
+          <a:p/>
+        </p:txBody>
       </p:sp>
       <p:sp>
         <p:nvSpPr>
@@ -1633,6 +1649,10 @@
             <a:prstDash val="solid"/>
           </a:ln>
         </p:spPr>
+        <p:txBody>
+          <a:bodyPr/>
+          <a:p/>
+        </p:txBody>
       </p:sp>
       <p:sp>
         <p:nvSpPr>
@@ -1658,6 +1678,10 @@
             <a:prstDash val="solid"/>
           </a:ln>
         </p:spPr>
+        <p:txBody>
+          <a:bodyPr/>
+          <a:p/>
+        </p:txBody>
       </p:sp>
       <p:sp>
         <p:nvSpPr>
@@ -1724,6 +1748,10 @@
             <a:prstDash val="solid"/>
           </a:ln>
         </p:spPr>
+        <p:txBody>
+          <a:bodyPr/>
+          <a:p/>
+        </p:txBody>
       </p:sp>
       <p:sp>
         <p:nvSpPr>
@@ -1749,6 +1777,10 @@
             <a:prstDash val="solid"/>
           </a:ln>
         </p:spPr>
+        <p:txBody>
+          <a:bodyPr/>
+          <a:p/>
+        </p:txBody>
       </p:sp>
       <p:sp>
         <p:nvSpPr>
@@ -1815,6 +1847,10 @@
             <a:prstDash val="solid"/>
           </a:ln>
         </p:spPr>
+        <p:txBody>
+          <a:bodyPr/>
+          <a:p/>
+        </p:txBody>
       </p:sp>
       <p:sp>
         <p:nvSpPr>
@@ -1840,6 +1876,10 @@
             <a:prstDash val="solid"/>
           </a:ln>
         </p:spPr>
+        <p:txBody>
+          <a:bodyPr/>
+          <a:p/>
+        </p:txBody>
       </p:sp>
       <p:sp>
         <p:nvSpPr>
@@ -1906,6 +1946,10 @@
             <a:prstDash val="solid"/>
           </a:ln>
         </p:spPr>
+        <p:txBody>
+          <a:bodyPr/>
+          <a:p/>
+        </p:txBody>
       </p:sp>
       <p:sp>
         <p:nvSpPr>
@@ -1931,6 +1975,10 @@
             <a:prstDash val="solid"/>
           </a:ln>
         </p:spPr>
+        <p:txBody>
+          <a:bodyPr/>
+          <a:p/>
+        </p:txBody>
       </p:sp>
       <p:sp>
         <p:nvSpPr>
@@ -1993,6 +2041,10 @@
             <a:prstDash val="solid"/>
           </a:ln>
         </p:spPr>
+        <p:txBody>
+          <a:bodyPr/>
+          <a:p/>
+        </p:txBody>
       </p:sp>
       <p:sp>
         <p:nvSpPr>
@@ -2016,6 +2068,10 @@
             <a:prstDash val="solid"/>
           </a:ln>
         </p:spPr>
+        <p:txBody>
+          <a:bodyPr/>
+          <a:p/>
+        </p:txBody>
       </p:sp>
       <p:sp>
         <p:nvSpPr>
@@ -2119,6 +2175,10 @@
             <a:prstDash val="solid"/>
           </a:ln>
         </p:spPr>
+        <p:txBody>
+          <a:bodyPr/>
+          <a:p/>
+        </p:txBody>
       </p:sp>
       <p:sp>
         <p:nvSpPr>
@@ -2144,6 +2204,10 @@
             <a:prstDash val="solid"/>
           </a:ln>
         </p:spPr>
+        <p:txBody>
+          <a:bodyPr/>
+          <a:p/>
+        </p:txBody>
       </p:sp>
       <p:sp>
         <p:nvSpPr>
@@ -2364,6 +2428,10 @@
             <a:prstDash val="solid"/>
           </a:ln>
         </p:spPr>
+        <p:txBody>
+          <a:bodyPr/>
+          <a:p/>
+        </p:txBody>
       </p:sp>
       <p:sp>
         <p:nvSpPr>
@@ -2601,6 +2669,10 @@
             <a:prstDash val="solid"/>
           </a:ln>
         </p:spPr>
+        <p:txBody>
+          <a:bodyPr/>
+          <a:p/>
+        </p:txBody>
       </p:sp>
       <p:sp>
         <p:nvSpPr>
@@ -2626,6 +2698,10 @@
             <a:prstDash val="solid"/>
           </a:ln>
         </p:spPr>
+        <p:txBody>
+          <a:bodyPr/>
+          <a:p/>
+        </p:txBody>
       </p:sp>
       <p:sp>
         <p:nvSpPr>
@@ -2846,6 +2922,10 @@
             <a:prstDash val="solid"/>
           </a:ln>
         </p:spPr>
+        <p:txBody>
+          <a:bodyPr/>
+          <a:p/>
+        </p:txBody>
       </p:sp>
       <p:sp>
         <p:nvSpPr>
@@ -3036,7 +3116,7 @@
                 <a:ea typeface="Calibri" pitchFamily="34" charset="-122"/>
                 <a:cs typeface="Calibri" pitchFamily="34" charset="-120"/>
               </a:rPr>
-              <a:t>8 rules · SKILL.md / AGENT.md / configs</a:t>
+              <a:t>12 rules · SKILL.md / AGENT.md / configs</a:t>
             </a:r>
             <a:endParaRPr lang="en-US" sz="850" dirty="0"/>
           </a:p>
@@ -3144,6 +3224,10 @@
             <a:prstDash val="solid"/>
           </a:ln>
         </p:spPr>
+        <p:txBody>
+          <a:bodyPr/>
+          <a:p/>
+        </p:txBody>
       </p:sp>
       <p:sp>
         <p:nvSpPr>
@@ -3169,6 +3253,10 @@
             <a:prstDash val="solid"/>
           </a:ln>
         </p:spPr>
+        <p:txBody>
+          <a:bodyPr/>
+          <a:p/>
+        </p:txBody>
       </p:sp>
       <p:sp>
         <p:nvSpPr>
@@ -3389,6 +3477,10 @@
             <a:prstDash val="solid"/>
           </a:ln>
         </p:spPr>
+        <p:txBody>
+          <a:bodyPr/>
+          <a:p/>
+        </p:txBody>
       </p:sp>
       <p:sp>
         <p:nvSpPr>
@@ -3711,6 +3803,10 @@
             <a:prstDash val="solid"/>
           </a:ln>
         </p:spPr>
+        <p:txBody>
+          <a:bodyPr/>
+          <a:p/>
+        </p:txBody>
       </p:sp>
       <p:sp>
         <p:nvSpPr>
@@ -3736,6 +3832,10 @@
             <a:prstDash val="solid"/>
           </a:ln>
         </p:spPr>
+        <p:txBody>
+          <a:bodyPr/>
+          <a:p/>
+        </p:txBody>
       </p:sp>
       <p:sp>
         <p:nvSpPr>
@@ -3956,6 +4056,10 @@
             <a:prstDash val="solid"/>
           </a:ln>
         </p:spPr>
+        <p:txBody>
+          <a:bodyPr/>
+          <a:p/>
+        </p:txBody>
       </p:sp>
       <p:sp>
         <p:nvSpPr>
@@ -4320,7 +4424,7 @@
 </p:sld>
 </file>
 
-<file path=ppt/slides/slide8.xml><?xml version="1.0" encoding="utf-8"?>
+<file path=ppt/slides/slide2.xml><?xml version="1.0" encoding="utf-8"?>
 <p:sld xmlns:a="http://schemas.openxmlformats.org/drawingml/2006/main" xmlns:r="http://schemas.openxmlformats.org/officeDocument/2006/relationships" xmlns:p="http://schemas.openxmlformats.org/presentationml/2006/main">
   <p:cSld name="Slide 3">
     <p:bg>
@@ -4455,6 +4559,10 @@
             </a:outerShdw>
           </a:effectLst>
         </p:spPr>
+        <p:txBody>
+          <a:bodyPr/>
+          <a:p/>
+        </p:txBody>
       </p:sp>
       <p:sp>
         <p:nvSpPr>
@@ -4480,6 +4588,10 @@
             <a:prstDash val="solid"/>
           </a:ln>
         </p:spPr>
+        <p:txBody>
+          <a:bodyPr/>
+          <a:p/>
+        </p:txBody>
       </p:sp>
       <p:sp>
         <p:nvSpPr>
@@ -4617,6 +4729,10 @@
             </a:outerShdw>
           </a:effectLst>
         </p:spPr>
+        <p:txBody>
+          <a:bodyPr/>
+          <a:p/>
+        </p:txBody>
       </p:sp>
       <p:sp>
         <p:nvSpPr>
@@ -4642,6 +4758,10 @@
             <a:prstDash val="solid"/>
           </a:ln>
         </p:spPr>
+        <p:txBody>
+          <a:bodyPr/>
+          <a:p/>
+        </p:txBody>
       </p:sp>
       <p:sp>
         <p:nvSpPr>
@@ -4821,6 +4941,10 @@
             </a:outerShdw>
           </a:effectLst>
         </p:spPr>
+        <p:txBody>
+          <a:bodyPr/>
+          <a:p/>
+        </p:txBody>
       </p:sp>
       <p:sp>
         <p:nvSpPr>
@@ -4846,6 +4970,10 @@
             <a:prstDash val="solid"/>
           </a:ln>
         </p:spPr>
+        <p:txBody>
+          <a:bodyPr/>
+          <a:p/>
+        </p:txBody>
       </p:sp>
       <p:sp>
         <p:nvSpPr>
@@ -5004,6 +5132,10 @@
             </a:outerShdw>
           </a:effectLst>
         </p:spPr>
+        <p:txBody>
+          <a:bodyPr/>
+          <a:p/>
+        </p:txBody>
       </p:sp>
       <p:sp>
         <p:nvSpPr>
@@ -5029,6 +5161,10 @@
             <a:prstDash val="solid"/>
           </a:ln>
         </p:spPr>
+        <p:txBody>
+          <a:bodyPr/>
+          <a:p/>
+        </p:txBody>
       </p:sp>
       <p:sp>
         <p:nvSpPr>
@@ -5148,7 +5284,7 @@
                 </a:solidFill>
                 <a:latin typeface="Calibri" pitchFamily="34" charset="0"/>
               </a:rPr>
-              <a:t>Semgrep — 19 rules · Manifest — 8 rules</a:t>
+              <a:t>Semgrep — 19 rules · Manifest — 12 rules</a:t>
             </a:r>
             <a:endParaRPr lang="en-US" sz="850" dirty="0"/>
           </a:p>
@@ -5229,6 +5365,10 @@
             </a:outerShdw>
           </a:effectLst>
         </p:spPr>
+        <p:txBody>
+          <a:bodyPr/>
+          <a:p/>
+        </p:txBody>
       </p:sp>
       <p:sp>
         <p:nvSpPr>
@@ -5254,6 +5394,10 @@
             <a:prstDash val="solid"/>
           </a:ln>
         </p:spPr>
+        <p:txBody>
+          <a:bodyPr/>
+          <a:p/>
+        </p:txBody>
       </p:sp>
       <p:sp>
         <p:nvSpPr>
@@ -5433,6 +5577,10 @@
             </a:outerShdw>
           </a:effectLst>
         </p:spPr>
+        <p:txBody>
+          <a:bodyPr/>
+          <a:p/>
+        </p:txBody>
       </p:sp>
       <p:sp>
         <p:nvSpPr>
@@ -5458,6 +5606,10 @@
             <a:prstDash val="solid"/>
           </a:ln>
         </p:spPr>
+        <p:txBody>
+          <a:bodyPr/>
+          <a:p/>
+        </p:txBody>
       </p:sp>
       <p:sp>
         <p:nvSpPr>

</xml_diff>

<commit_message>
ppt: increase card fonts and box sizes on Slide 2 of Blueprint PPT
Labels 9→11pt, titles 13→15pt, body 8→10pt across all cards.
Cards scaled 18% wider and 15% taller; connector lines repositioned to match.

Co-Authored-By: Claude Sonnet 4.6 <noreply@anthropic.com>
</commit_message>
<xml_diff>
--- a/ppt/AgentShield-Blueprint-and-Flow.pptx
+++ b/ppt/AgentShield-Blueprint-and-Flow.pptx
@@ -4512,7 +4512,7 @@
               <a:buNone/>
             </a:pPr>
             <a:r>
-              <a:rPr lang="en-US" sz="1250" i="1" dirty="0">
+              <a:rPr lang="en-US" sz="1500" i="1" dirty="0">
                 <a:solidFill>
                   <a:srgbClr val="6B5D4F"/>
                 </a:solidFill>
@@ -4534,8 +4534,8 @@
         </p:nvSpPr>
         <p:spPr>
           <a:xfrm>
-            <a:off x="1266000" y="3250000"/>
-            <a:ext cx="1700000" cy="1500000"/>
+            <a:off x="1113000" y="3137501"/>
+            <a:ext cx="2006000" cy="1724999"/>
           </a:xfrm>
           <a:prstGeom prst="roundRect">
             <a:avLst>
@@ -4572,8 +4572,8 @@
         </p:nvSpPr>
         <p:spPr>
           <a:xfrm>
-            <a:off x="1266000" y="3250000"/>
-            <a:ext cx="1700000" cy="64008"/>
+            <a:off x="1113000" y="3137501"/>
+            <a:ext cx="2006000" cy="64008"/>
           </a:xfrm>
           <a:prstGeom prst="rect">
             <a:avLst/>
@@ -4601,8 +4601,8 @@
         </p:nvSpPr>
         <p:spPr>
           <a:xfrm>
-            <a:off x="1376000" y="3400000"/>
-            <a:ext cx="1480000" cy="1250000"/>
+            <a:off x="1223000" y="3287501"/>
+            <a:ext cx="1786000" cy="1524999"/>
           </a:xfrm>
           <a:prstGeom prst="rect">
             <a:avLst/>
@@ -4621,7 +4621,7 @@
               <a:buNone/>
             </a:pPr>
             <a:r>
-              <a:rPr lang="en-US" sz="900" b="1" spc="200" dirty="0">
+              <a:rPr lang="en-US" sz="1100" b="1" spc="200" dirty="0">
                 <a:solidFill>
                   <a:srgbClr val="5E3A24"/>
                 </a:solidFill>
@@ -4642,7 +4642,7 @@
               <a:buNone/>
             </a:pPr>
             <a:r>
-              <a:rPr lang="en-US" sz="1300" b="1" dirty="0">
+              <a:rPr lang="en-US" sz="1500" b="1" dirty="0">
                 <a:solidFill>
                   <a:srgbClr val="000000"/>
                 </a:solidFill>
@@ -4663,7 +4663,7 @@
               <a:buNone/>
             </a:pPr>
             <a:r>
-              <a:rPr lang="en-US" sz="850" dirty="0">
+              <a:rPr lang="en-US" sz="1100" dirty="0">
                 <a:solidFill>
                   <a:srgbClr val="334155"/>
                 </a:solidFill>
@@ -4684,7 +4684,7 @@
               <a:buNone/>
             </a:pPr>
             <a:r>
-              <a:rPr lang="en-US" sz="850" dirty="0">
+              <a:rPr lang="en-US" sz="1100" dirty="0">
                 <a:solidFill>
                   <a:srgbClr val="334155"/>
                 </a:solidFill>
@@ -4704,8 +4704,8 @@
         </p:nvSpPr>
         <p:spPr>
           <a:xfrm>
-            <a:off x="6806000" y="3250000"/>
-            <a:ext cx="1700000" cy="1500000"/>
+            <a:off x="6653000" y="3137501"/>
+            <a:ext cx="2006000" cy="1724999"/>
           </a:xfrm>
           <a:prstGeom prst="roundRect">
             <a:avLst>
@@ -4742,8 +4742,8 @@
         </p:nvSpPr>
         <p:spPr>
           <a:xfrm>
-            <a:off x="6806000" y="3250000"/>
-            <a:ext cx="1700000" cy="64008"/>
+            <a:off x="6653000" y="3137501"/>
+            <a:ext cx="2006000" cy="64008"/>
           </a:xfrm>
           <a:prstGeom prst="rect">
             <a:avLst/>
@@ -4771,8 +4771,8 @@
         </p:nvSpPr>
         <p:spPr>
           <a:xfrm>
-            <a:off x="6916000" y="3400000"/>
-            <a:ext cx="1480000" cy="1250000"/>
+            <a:off x="6763000" y="3287501"/>
+            <a:ext cx="1786000" cy="1524999"/>
           </a:xfrm>
           <a:prstGeom prst="rect">
             <a:avLst/>
@@ -4791,7 +4791,7 @@
               <a:buNone/>
             </a:pPr>
             <a:r>
-              <a:rPr lang="en-US" sz="900" b="1" spc="200" dirty="0">
+              <a:rPr lang="en-US" sz="1100" b="1" spc="200" dirty="0">
                 <a:solidFill>
                   <a:srgbClr val="4A7FA7"/>
                 </a:solidFill>
@@ -4812,7 +4812,7 @@
               <a:buNone/>
             </a:pPr>
             <a:r>
-              <a:rPr lang="en-US" sz="1300" b="1" dirty="0">
+              <a:rPr lang="en-US" sz="1500" b="1" dirty="0">
                 <a:solidFill>
                   <a:srgbClr val="000000"/>
                 </a:solidFill>
@@ -4833,7 +4833,7 @@
               <a:buNone/>
             </a:pPr>
             <a:r>
-              <a:rPr lang="en-US" sz="800" i="1" dirty="0">
+              <a:rPr lang="en-US" sz="1000" i="1" dirty="0">
                 <a:solidFill>
                   <a:srgbClr val="6B5D4F"/>
                 </a:solidFill>
@@ -4854,7 +4854,7 @@
               <a:buNone/>
             </a:pPr>
             <a:r>
-              <a:rPr lang="en-US" sz="900" b="1" dirty="0">
+              <a:rPr lang="en-US" sz="1100" b="1" dirty="0">
                 <a:solidFill>
                   <a:srgbClr val="1A1A1A"/>
                 </a:solidFill>
@@ -4875,7 +4875,7 @@
               <a:buNone/>
             </a:pPr>
             <a:r>
-              <a:rPr lang="en-US" sz="850" dirty="0">
+              <a:rPr lang="en-US" sz="1100" dirty="0">
                 <a:solidFill>
                   <a:srgbClr val="334155"/>
                 </a:solidFill>
@@ -4896,7 +4896,7 @@
               <a:buNone/>
             </a:pPr>
             <a:r>
-              <a:rPr lang="en-US" sz="850" dirty="0">
+              <a:rPr lang="en-US" sz="1100" dirty="0">
                 <a:solidFill>
                   <a:srgbClr val="334155"/>
                 </a:solidFill>
@@ -4916,8 +4916,8 @@
         </p:nvSpPr>
         <p:spPr>
           <a:xfrm>
-            <a:off x="9226000" y="3250000"/>
-            <a:ext cx="1700000" cy="1500000"/>
+            <a:off x="9073000" y="3137501"/>
+            <a:ext cx="2006000" cy="1724999"/>
           </a:xfrm>
           <a:prstGeom prst="roundRect">
             <a:avLst>
@@ -4954,8 +4954,8 @@
         </p:nvSpPr>
         <p:spPr>
           <a:xfrm>
-            <a:off x="9226000" y="3250000"/>
-            <a:ext cx="1700000" cy="64008"/>
+            <a:off x="9073000" y="3137501"/>
+            <a:ext cx="2006000" cy="64008"/>
           </a:xfrm>
           <a:prstGeom prst="rect">
             <a:avLst/>
@@ -4983,8 +4983,8 @@
         </p:nvSpPr>
         <p:spPr>
           <a:xfrm>
-            <a:off x="9336000" y="3400000"/>
-            <a:ext cx="1480000" cy="1250000"/>
+            <a:off x="9183000" y="3287501"/>
+            <a:ext cx="1786000" cy="1524999"/>
           </a:xfrm>
           <a:prstGeom prst="rect">
             <a:avLst/>
@@ -5003,7 +5003,7 @@
               <a:buNone/>
             </a:pPr>
             <a:r>
-              <a:rPr lang="en-US" sz="900" b="1" spc="200" dirty="0">
+              <a:rPr lang="en-US" sz="1100" b="1" spc="200" dirty="0">
                 <a:solidFill>
                   <a:srgbClr val="5E3A24"/>
                 </a:solidFill>
@@ -5024,7 +5024,7 @@
               <a:buNone/>
             </a:pPr>
             <a:r>
-              <a:rPr lang="en-US" sz="1300" b="1" dirty="0">
+              <a:rPr lang="en-US" sz="1500" b="1" dirty="0">
                 <a:solidFill>
                   <a:srgbClr val="000000"/>
                 </a:solidFill>
@@ -5045,7 +5045,7 @@
               <a:buNone/>
             </a:pPr>
             <a:r>
-              <a:rPr lang="en-US" sz="800" i="1" dirty="0">
+              <a:rPr lang="en-US" sz="1000" i="1" dirty="0">
                 <a:solidFill>
                   <a:srgbClr val="6B5D4F"/>
                 </a:solidFill>
@@ -5066,7 +5066,7 @@
               <a:buNone/>
             </a:pPr>
             <a:r>
-              <a:rPr lang="en-US" sz="850" dirty="0">
+              <a:rPr lang="en-US" sz="1100" dirty="0">
                 <a:solidFill>
                   <a:srgbClr val="334155"/>
                 </a:solidFill>
@@ -5087,7 +5087,7 @@
               <a:buNone/>
             </a:pPr>
             <a:r>
-              <a:rPr lang="en-US" sz="850" dirty="0">
+              <a:rPr lang="en-US" sz="1100" dirty="0">
                 <a:solidFill>
                   <a:srgbClr val="334155"/>
                 </a:solidFill>
@@ -5107,8 +5107,8 @@
         </p:nvSpPr>
         <p:spPr>
           <a:xfrm>
-            <a:off x="3686000" y="1625000"/>
-            <a:ext cx="2400000" cy="1450000"/>
+            <a:off x="3470000" y="1200000"/>
+            <a:ext cx="2832000" cy="1669333"/>
           </a:xfrm>
           <a:prstGeom prst="roundRect">
             <a:avLst>
@@ -5145,8 +5145,8 @@
         </p:nvSpPr>
         <p:spPr>
           <a:xfrm>
-            <a:off x="3686000" y="1625000"/>
-            <a:ext cx="2400000" cy="64008"/>
+            <a:off x="3470000" y="1200000"/>
+            <a:ext cx="2832000" cy="64008"/>
           </a:xfrm>
           <a:prstGeom prst="rect">
             <a:avLst/>
@@ -5174,8 +5174,8 @@
         </p:nvSpPr>
         <p:spPr>
           <a:xfrm>
-            <a:off x="3796000" y="1775000"/>
-            <a:ext cx="2180000" cy="1200000"/>
+            <a:off x="3580000" y="1350000"/>
+            <a:ext cx="2612000" cy="1469333"/>
           </a:xfrm>
           <a:prstGeom prst="rect">
             <a:avLst/>
@@ -5194,7 +5194,7 @@
               <a:buNone/>
             </a:pPr>
             <a:r>
-              <a:rPr lang="en-US" sz="900" b="1" spc="200" dirty="0">
+              <a:rPr lang="en-US" sz="1100" b="1" spc="200" dirty="0">
                 <a:solidFill>
                   <a:srgbClr val="5E3A24"/>
                 </a:solidFill>
@@ -5215,7 +5215,7 @@
               <a:buNone/>
             </a:pPr>
             <a:r>
-              <a:rPr lang="en-US" sz="1300" b="1" dirty="0">
+              <a:rPr lang="en-US" sz="1500" b="1" dirty="0">
                 <a:solidFill>
                   <a:srgbClr val="000000"/>
                 </a:solidFill>
@@ -5236,7 +5236,7 @@
               <a:buNone/>
             </a:pPr>
             <a:r>
-              <a:rPr lang="en-US" sz="800" i="1" dirty="0">
+              <a:rPr lang="en-US" sz="1000" i="1" dirty="0">
                 <a:solidFill>
                   <a:srgbClr val="6B5D4F"/>
                 </a:solidFill>
@@ -5257,7 +5257,7 @@
               <a:buNone/>
             </a:pPr>
             <a:r>
-              <a:rPr lang="en-US" sz="900" b="1" dirty="0">
+              <a:rPr lang="en-US" sz="1100" b="1" dirty="0">
                 <a:solidFill>
                   <a:srgbClr val="1A1A1A"/>
                 </a:solidFill>
@@ -5278,7 +5278,7 @@
               <a:buNone/>
             </a:pPr>
             <a:r>
-              <a:rPr lang="en-US" sz="850" dirty="0">
+              <a:rPr lang="en-US" sz="1100" dirty="0">
                 <a:solidFill>
                   <a:srgbClr val="334155"/>
                 </a:solidFill>
@@ -5299,7 +5299,7 @@
               <a:buNone/>
             </a:pPr>
             <a:r>
-              <a:rPr lang="en-US" sz="750" i="1" dirty="0">
+              <a:rPr lang="en-US" sz="1000" i="1" dirty="0">
                 <a:solidFill>
                   <a:srgbClr val="8F5A39"/>
                 </a:solidFill>
@@ -5320,7 +5320,7 @@
               <a:buNone/>
             </a:pPr>
             <a:r>
-              <a:rPr lang="en-US" sz="850" b="1" dirty="0">
+              <a:rPr lang="en-US" sz="1100" b="1" dirty="0">
                 <a:solidFill>
                   <a:srgbClr val="1A1A1A"/>
                 </a:solidFill>
@@ -5340,8 +5340,8 @@
         </p:nvSpPr>
         <p:spPr>
           <a:xfrm>
-            <a:off x="3686000" y="3275000"/>
-            <a:ext cx="2400000" cy="1450000"/>
+            <a:off x="3470000" y="3019333"/>
+            <a:ext cx="2832000" cy="1669333"/>
           </a:xfrm>
           <a:prstGeom prst="roundRect">
             <a:avLst>
@@ -5378,8 +5378,8 @@
         </p:nvSpPr>
         <p:spPr>
           <a:xfrm>
-            <a:off x="3686000" y="3275000"/>
-            <a:ext cx="2400000" cy="64008"/>
+            <a:off x="3470000" y="3019333"/>
+            <a:ext cx="2832000" cy="64008"/>
           </a:xfrm>
           <a:prstGeom prst="rect">
             <a:avLst/>
@@ -5407,8 +5407,8 @@
         </p:nvSpPr>
         <p:spPr>
           <a:xfrm>
-            <a:off x="3796000" y="3425000"/>
-            <a:ext cx="2180000" cy="1200000"/>
+            <a:off x="3580000" y="3169333"/>
+            <a:ext cx="2612000" cy="1469333"/>
           </a:xfrm>
           <a:prstGeom prst="rect">
             <a:avLst/>
@@ -5427,7 +5427,7 @@
               <a:buNone/>
             </a:pPr>
             <a:r>
-              <a:rPr lang="en-US" sz="900" b="1" spc="200" dirty="0">
+              <a:rPr lang="en-US" sz="1100" b="1" spc="200" dirty="0">
                 <a:solidFill>
                   <a:srgbClr val="5E3A24"/>
                 </a:solidFill>
@@ -5448,7 +5448,7 @@
               <a:buNone/>
             </a:pPr>
             <a:r>
-              <a:rPr lang="en-US" sz="1300" b="1" dirty="0">
+              <a:rPr lang="en-US" sz="1500" b="1" dirty="0">
                 <a:solidFill>
                   <a:srgbClr val="000000"/>
                 </a:solidFill>
@@ -5469,7 +5469,7 @@
               <a:buNone/>
             </a:pPr>
             <a:r>
-              <a:rPr lang="en-US" sz="800" i="1" dirty="0">
+              <a:rPr lang="en-US" sz="1000" i="1" dirty="0">
                 <a:solidFill>
                   <a:srgbClr val="6B5D4F"/>
                 </a:solidFill>
@@ -5490,7 +5490,7 @@
               <a:buNone/>
             </a:pPr>
             <a:r>
-              <a:rPr lang="en-US" sz="850" dirty="0">
+              <a:rPr lang="en-US" sz="1100" dirty="0">
                 <a:solidFill>
                   <a:srgbClr val="334155"/>
                 </a:solidFill>
@@ -5511,7 +5511,7 @@
               <a:buNone/>
             </a:pPr>
             <a:r>
-              <a:rPr lang="en-US" sz="750" i="1" dirty="0">
+              <a:rPr lang="en-US" sz="1000" i="1" dirty="0">
                 <a:solidFill>
                   <a:srgbClr val="8F5A39"/>
                 </a:solidFill>
@@ -5532,7 +5532,7 @@
               <a:buNone/>
             </a:pPr>
             <a:r>
-              <a:rPr lang="en-US" sz="850" b="1" dirty="0">
+              <a:rPr lang="en-US" sz="1100" b="1" dirty="0">
                 <a:solidFill>
                   <a:srgbClr val="1A1A1A"/>
                 </a:solidFill>
@@ -5552,8 +5552,8 @@
         </p:nvSpPr>
         <p:spPr>
           <a:xfrm>
-            <a:off x="3686000" y="4925000"/>
-            <a:ext cx="2400000" cy="1450000"/>
+            <a:off x="3470000" y="4838666"/>
+            <a:ext cx="2832000" cy="1669333"/>
           </a:xfrm>
           <a:prstGeom prst="roundRect">
             <a:avLst>
@@ -5590,8 +5590,8 @@
         </p:nvSpPr>
         <p:spPr>
           <a:xfrm>
-            <a:off x="3686000" y="4925000"/>
-            <a:ext cx="2400000" cy="64008"/>
+            <a:off x="3470000" y="4838666"/>
+            <a:ext cx="2832000" cy="64008"/>
           </a:xfrm>
           <a:prstGeom prst="rect">
             <a:avLst/>
@@ -5619,8 +5619,8 @@
         </p:nvSpPr>
         <p:spPr>
           <a:xfrm>
-            <a:off x="3796000" y="5075000"/>
-            <a:ext cx="2180000" cy="1200000"/>
+            <a:off x="3580000" y="4988666"/>
+            <a:ext cx="2612000" cy="1469333"/>
           </a:xfrm>
           <a:prstGeom prst="rect">
             <a:avLst/>
@@ -5639,7 +5639,7 @@
               <a:buNone/>
             </a:pPr>
             <a:r>
-              <a:rPr lang="en-US" sz="900" b="1" spc="200" dirty="0">
+              <a:rPr lang="en-US" sz="1100" b="1" spc="200" dirty="0">
                 <a:solidFill>
                   <a:srgbClr val="5E3A24"/>
                 </a:solidFill>
@@ -5660,7 +5660,7 @@
               <a:buNone/>
             </a:pPr>
             <a:r>
-              <a:rPr lang="en-US" sz="1300" b="1" dirty="0">
+              <a:rPr lang="en-US" sz="1500" b="1" dirty="0">
                 <a:solidFill>
                   <a:srgbClr val="000000"/>
                 </a:solidFill>
@@ -5681,7 +5681,7 @@
               <a:buNone/>
             </a:pPr>
             <a:r>
-              <a:rPr lang="en-US" sz="800" i="1" dirty="0">
+              <a:rPr lang="en-US" sz="1000" i="1" dirty="0">
                 <a:solidFill>
                   <a:srgbClr val="6B5D4F"/>
                 </a:solidFill>
@@ -5702,7 +5702,7 @@
               <a:buNone/>
             </a:pPr>
             <a:r>
-              <a:rPr lang="en-US" sz="850" dirty="0">
+              <a:rPr lang="en-US" sz="1100" dirty="0">
                 <a:solidFill>
                   <a:srgbClr val="334155"/>
                 </a:solidFill>
@@ -5723,7 +5723,7 @@
               <a:buNone/>
             </a:pPr>
             <a:r>
-              <a:rPr lang="en-US" sz="750" i="1" dirty="0">
+              <a:rPr lang="en-US" sz="1000" i="1" dirty="0">
                 <a:solidFill>
                   <a:srgbClr val="8F5A39"/>
                 </a:solidFill>
@@ -5744,7 +5744,7 @@
               <a:buNone/>
             </a:pPr>
             <a:r>
-              <a:rPr lang="en-US" sz="800" b="1" dirty="0">
+              <a:rPr lang="en-US" sz="1000" b="1" dirty="0">
                 <a:solidFill>
                   <a:srgbClr val="1A1A1A"/>
                 </a:solidFill>
@@ -5764,8 +5764,8 @@
         </p:nvCxnSpPr>
         <p:spPr>
           <a:xfrm>
-            <a:off x="2966000" y="4000000"/>
-            <a:ext cx="360000" cy="1"/>
+            <a:off x="3119000" y="3853999"/>
+            <a:ext cx="175500" cy="1"/>
           </a:xfrm>
           <a:prstGeom prst="line">
             <a:avLst/>
@@ -5785,8 +5785,8 @@
         </p:nvCxnSpPr>
         <p:spPr>
           <a:xfrm flipV="1">
-            <a:off x="3326000" y="2350000"/>
-            <a:ext cx="1" cy="1650000"/>
+            <a:off x="3294500" y="2034666"/>
+            <a:ext cx="1" cy="1819333"/>
           </a:xfrm>
           <a:prstGeom prst="line">
             <a:avLst/>
@@ -5806,8 +5806,8 @@
         </p:nvCxnSpPr>
         <p:spPr>
           <a:xfrm>
-            <a:off x="3326000" y="2350000"/>
-            <a:ext cx="360000" cy="1"/>
+            <a:off x="3294500" y="2034666"/>
+            <a:ext cx="175500" cy="1"/>
           </a:xfrm>
           <a:prstGeom prst="line">
             <a:avLst/>
@@ -5828,8 +5828,8 @@
         </p:nvCxnSpPr>
         <p:spPr>
           <a:xfrm>
-            <a:off x="4886000" y="3075000"/>
-            <a:ext cx="1" cy="200000"/>
+            <a:off x="4886000" y="2869333"/>
+            <a:ext cx="1" cy="150000"/>
           </a:xfrm>
           <a:prstGeom prst="line">
             <a:avLst/>
@@ -5850,8 +5850,8 @@
         </p:nvCxnSpPr>
         <p:spPr>
           <a:xfrm>
-            <a:off x="4886000" y="4725000"/>
-            <a:ext cx="1" cy="200000"/>
+            <a:off x="4886000" y="4688666"/>
+            <a:ext cx="1" cy="150000"/>
           </a:xfrm>
           <a:prstGeom prst="line">
             <a:avLst/>
@@ -5872,8 +5872,8 @@
         </p:nvCxnSpPr>
         <p:spPr>
           <a:xfrm>
-            <a:off x="6086000" y="5650000"/>
-            <a:ext cx="360000" cy="1"/>
+            <a:off x="6302000" y="4000000"/>
+            <a:ext cx="175500" cy="1"/>
           </a:xfrm>
           <a:prstGeom prst="line">
             <a:avLst/>
@@ -5893,8 +5893,8 @@
         </p:nvCxnSpPr>
         <p:spPr>
           <a:xfrm flipV="1">
-            <a:off x="6446000" y="4000000"/>
-            <a:ext cx="1" cy="1650000"/>
+            <a:off x="6477500" y="3853999"/>
+            <a:ext cx="1" cy="146001"/>
           </a:xfrm>
           <a:prstGeom prst="line">
             <a:avLst/>
@@ -5914,8 +5914,8 @@
         </p:nvCxnSpPr>
         <p:spPr>
           <a:xfrm>
-            <a:off x="6446000" y="4000000"/>
-            <a:ext cx="360000" cy="1"/>
+            <a:off x="6477500" y="4000000"/>
+            <a:ext cx="175500" cy="1"/>
           </a:xfrm>
           <a:prstGeom prst="line">
             <a:avLst/>
@@ -5936,8 +5936,8 @@
         </p:nvCxnSpPr>
         <p:spPr>
           <a:xfrm>
-            <a:off x="8506000" y="4000000"/>
-            <a:ext cx="720000" cy="1"/>
+            <a:off x="8659000" y="4000000"/>
+            <a:ext cx="414000" cy="1"/>
           </a:xfrm>
           <a:prstGeom prst="line">
             <a:avLst/>
@@ -5975,7 +5975,7 @@
               <a:buNone/>
             </a:pPr>
             <a:r>
-              <a:rPr lang="en-US" sz="1200" b="1" dirty="0">
+              <a:rPr lang="en-US" sz="1400" b="1" dirty="0">
                 <a:solidFill>
                   <a:srgbClr val="000000"/>
                 </a:solidFill>
@@ -5989,7 +5989,7 @@
               <a:buNone/>
             </a:pPr>
             <a:r>
-              <a:rPr lang="en-US" sz="1200" i="1" dirty="0">
+              <a:rPr lang="en-US" sz="1400" i="1" dirty="0">
                 <a:solidFill>
                   <a:srgbClr val="6B5D4F"/>
                 </a:solidFill>

</xml_diff>